<commit_message>
chore(brand): company name to "Santa Rosa Paraguay SA" everywhere
Replaces all "Santa Rosa Automotores" / "Santa Rosa SA" mentions with the
correct legal name "Santa Rosa Paraguay SA" across the email templates footer,
auction-won page, payment form placeholder, login footer + feature copy, the
app metadata description, and the onboarding decks (content JSON + rebuilt
HTML/pptx).

Co-Authored-By: Claude Opus 4.6 <noreply@anthropic.com>
</commit_message>
<xml_diff>
--- a/docs/onboarding/pptx/01-general.pptx
+++ b/docs/onboarding/pptx/01-general.pptx
@@ -3280,7 +3280,7 @@
                 </a:solidFill>
                 <a:latin typeface="Calibri"/>
               </a:rPr>
-              <a:t>La plataforma de subastas de vehículos de Santa Rosa Automotores, explicada de principio a fin.</a:t>
+              <a:t>La plataforma de subastas de vehículos de Santa Rosa Paraguay SA, explicada de principio a fin.</a:t>
             </a:r>
           </a:p>
         </p:txBody>
@@ -3323,7 +3323,7 @@
                 </a:solidFill>
                 <a:latin typeface="Calibri"/>
               </a:rPr>
-              <a:t>    Santa Rosa Automotores · Paraguay</a:t>
+              <a:t>    Santa Rosa Paraguay SA · Paraguay</a:t>
             </a:r>
           </a:p>
         </p:txBody>
@@ -11137,7 +11137,7 @@
                 </a:solidFill>
                 <a:latin typeface="Calibri"/>
               </a:rPr>
-              <a:t>Renew Subastas · Santa Rosa Automotores · Paraguay</a:t>
+              <a:t>Renew Subastas · Santa Rosa Paraguay SA · Paraguay</a:t>
             </a:r>
           </a:p>
         </p:txBody>
@@ -11327,7 +11327,7 @@
                 </a:solidFill>
                 <a:latin typeface="Calibri"/>
               </a:rPr>
-              <a:t>Renew Subastas digitaliza el remate de vehículos de Santa Rosa Automotores. El equipo carga autos y programa subastas con horario; los compradores registrados ofertan en vivo desde la web.</a:t>
+              <a:t>Renew Subastas digitaliza el remate de vehículos de Santa Rosa Paraguay SA. El equipo carga autos y programa subastas con horario; los compradores registrados ofertan en vivo desde la web.</a:t>
             </a:r>
           </a:p>
         </p:txBody>

</xml_diff>